<commit_message>
docs(slides): speaker notes and demo labels for phone signing on the night's own chain
Rebuilt both PowerPoint decks and the HTML deck from the new SPEECH.md. The demo running head
now says 'simulated bank, private test chain', and DEMO 1's divider mentions the phones. The
PDF exports in slides/ still need LibreOffice to regenerate (slides/deck.sh).

Co-Authored-By: Claude Opus 5.5 <noreply@anthropic.com>
</commit_message>
<xml_diff>
--- a/slides/The-Treasurer-Is-a-Smart-Contract-Light.pptx
+++ b/slides/The-Treasurer-Is-a-Smart-Contract-Light.pptx
@@ -1371,18 +1371,13 @@
           <a:p/>
           <a:p>
             <a:r>
-              <a:t>I need four of you at the signing station. Any four. Scan your card, read the sentence, press</a:t>
+              <a:t>Any four of you: scan your card again, read the sentence, press Sign.</a:t>
             </a:r>
           </a:p>
+          <a:p/>
           <a:p>
             <a:r>
-              <a:t>Sign.</a:t>
-            </a:r>
-          </a:p>
-          <a:p/>
-          <a:p>
-            <a:r>
-              <a:t>[As the first slip shows:]</a:t>
+              <a:t>[As the first phone shows the slip:]</a:t>
             </a:r>
           </a:p>
           <a:p/>
@@ -1571,7 +1566,7 @@
           <a:p/>
           <a:p>
             <a:r>
-              <a:t>[Get four votes at the station, then execute.]</a:t>
+              <a:t>[Four volunteers scan and sign on their phones, then execute.]</a:t>
             </a:r>
           </a:p>
           <a:p/>
@@ -1589,7 +1584,7 @@
           <a:p/>
           <a:p>
             <a:r>
-              <a:t>Signing station: scan the old card 06.</a:t>
+              <a:t>Your phone: scan the old card 06.</a:t>
             </a:r>
           </a:p>
           <a:p/>
@@ -1617,7 +1612,7 @@
           <a:p/>
           <a:p>
             <a:r>
-              <a:t>[Sipho scans 06b.]</a:t>
+              <a:t>[Sipho scans 06b with a phone.]</a:t>
             </a:r>
           </a:p>
           <a:p/>
@@ -1875,7 +1870,17 @@
           <a:p/>
           <a:p>
             <a:r>
-              <a:t>And these cards should be passkeys. A phone that signs, not a QR you can photograph.</a:t>
+              <a:t>And these cards should be passkeys. Tonight you scanned a key into a website. That is exactly</a:t>
+            </a:r>
+          </a:p>
+          <a:p>
+            <a:r>
+              <a:t>what a crypto scam looks like, and in real life you never do it. A phone that signs, not a QR</a:t>
+            </a:r>
+          </a:p>
+          <a:p>
+            <a:r>
+              <a:t>you can photograph.</a:t>
             </a:r>
           </a:p>
           <a:p/>
@@ -2735,7 +2740,7 @@
           <a:p/>
           <a:p>
             <a:r>
-              <a:t>Before anything moves: everything you see tonight is the Investec sandbox and a test network.</a:t>
+              <a:t>Before anything moves: everything you see tonight is a simulated bank and a private test chain.</a:t>
             </a:r>
           </a:p>
           <a:p>
@@ -2768,24 +2773,35 @@
           <a:p/>
           <a:p>
             <a:r>
-              <a:t>[Point at the signing station.]</a:t>
+              <a:t>Committee, take out your phones. Turn your card over and point your camera at the QR on the</a:t>
             </a:r>
           </a:p>
+          <a:p>
+            <a:r>
+              <a:t>back. Tap the link it offers.</a:t>
+            </a:r>
+          </a:p>
           <a:p/>
           <a:p>
             <a:r>
-              <a:t>Lerato, come and be first. Turn your card over, hold the QR to the scanner.</a:t>
+              <a:t>Volunteers' phones: each opens /sign holding their card. Lerato's slip says "Lerato signs the</a:t>
             </a:r>
           </a:p>
+          <a:p>
+            <a:r>
+              <a:t>constitution of The Q4 Stokvel."</a:t>
+            </a:r>
+          </a:p>
           <a:p/>
           <a:p>
             <a:r>
-              <a:t>Signing station: scan card 01. The slip shows "Lerato signs the constitution of The Q4</a:t>
+              <a:t>Lerato, read me what your phone says.</a:t>
             </a:r>
           </a:p>
+          <a:p/>
           <a:p>
             <a:r>
-              <a:t>Stokvel." Press Sign.</a:t>
+              <a:t>[She reads it.]</a:t>
             </a:r>
           </a:p>
           <a:p/>
@@ -2796,46 +2812,46 @@
           </a:p>
           <a:p>
             <a:r>
-              <a:t>contract only accepts it because that card is member one. Press the button.</a:t>
+              <a:t>contract only accepts it because that card is member one. Press Sign.</a:t>
             </a:r>
           </a:p>
           <a:p/>
           <a:p>
             <a:r>
-              <a:t>[Wait for the minute book line: "Member joined".]</a:t>
+              <a:t>[Wait for the minute book line: "Member joined", and "✓ signed in" next to Lerato on the roster.]</a:t>
             </a:r>
           </a:p>
           <a:p/>
           <a:p>
             <a:r>
-              <a:t>And there it is on the right page. Nobody typed her name in. The chain knows her from the</a:t>
+              <a:t>And there she is on the right page. Signed in. Nobody typed her name in. The chain knows her</a:t>
             </a:r>
           </a:p>
           <a:p>
             <a:r>
-              <a:t>signature.</a:t>
+              <a:t>from the signature. Everybody else on the committee: Sign.</a:t>
             </a:r>
           </a:p>
           <a:p/>
           <a:p>
             <a:r>
-              <a:t>[Get the other five through the station quickly. Talk over it.]</a:t>
+              <a:t>[The other five land in a few seconds. Talk over it. If a phone won't scan, that card goes to</a:t>
             </a:r>
           </a:p>
+          <a:p>
+            <a:r>
+              <a:t>the signing station at the side.]</a:t>
+            </a:r>
+          </a:p>
           <a:p/>
           <a:p>
             <a:r>
-              <a:t>While the rest of the committee signs, everybody else: scan the QR on the screen. That's the</a:t>
+              <a:t>While they sign, everybody else: scan the QR on the screen. That's the audience page. Read only,</a:t>
             </a:r>
           </a:p>
           <a:p>
             <a:r>
-              <a:t>audience page. Read only, same as the projector, and every line links to the block explorer. You</a:t>
-            </a:r>
-          </a:p>
-          <a:p>
-            <a:r>
-              <a:t>don't have to take my word for any of this.</a:t>
+              <a:t>the same record the projector shows, live on your phone.</a:t>
             </a:r>
           </a:p>
         </p:txBody>
@@ -2995,38 +3011,28 @@
           <a:p/>
           <a:p>
             <a:r>
-              <a:t>If you're on the audience page, that event has a hash. Tap it. That's the contract, on a public</a:t>
+              <a:t>If you're on the audience page, that event has its transaction fingerprint next to it. That's</a:t>
             </a:r>
           </a:p>
           <a:p>
             <a:r>
-              <a:t>test network, telling you what just happened, without me in the way.</a:t>
+              <a:t>the contract's record of what just happened, not mine.</a:t>
             </a:r>
           </a:p>
           <a:p/>
           <a:p>
             <a:r>
-              <a:t>One honest note, because this is a room that will ask. Investec's sandbox is stateless. A</a:t>
+              <a:t>One honest note, because this is a room that will ask. The bank tonight is a mock of Investec's</a:t>
             </a:r>
           </a:p>
           <a:p>
             <a:r>
-              <a:t>transfer in the sandbox returns a real payment reference and then nothing changes. So on stage</a:t>
+              <a:t>API, the same calls and the same shapes. The relayer can't tell the difference, and that's the</a:t>
             </a:r>
           </a:p>
           <a:p>
             <a:r>
-              <a:t>the money moves in a mirror of the sandbox that speaks the same API, byte for byte, and every</a:t>
-            </a:r>
-          </a:p>
-          <a:p>
-            <a:r>
-              <a:t>payout is also sent to the real sandbox, which answers with a real reference. You'll see one</a:t>
-            </a:r>
-          </a:p>
-          <a:p>
-            <a:r>
-              <a:t>later. The relayer can't tell the difference, and that's the test.</a:t>
+              <a:t>test. The repo runs it against the real sandbox too.</a:t>
             </a:r>
           </a:p>
         </p:txBody>
@@ -16364,7 +16370,7 @@
                 </a:solidFill>
                 <a:latin typeface="JetBrains Mono"/>
               </a:rPr>
-              <a:t>live · sandbox and testnet only</a:t>
+              <a:t>live · simulated bank, private test chain</a:t>
             </a:r>
           </a:p>
         </p:txBody>
@@ -21396,7 +21402,7 @@
                 </a:solidFill>
                 <a:latin typeface="JetBrains Mono"/>
               </a:rPr>
-              <a:t>live · sandbox and testnet only</a:t>
+              <a:t>live · simulated bank, private test chain</a:t>
             </a:r>
           </a:p>
         </p:txBody>
@@ -27772,7 +27778,7 @@
                 </a:solidFill>
                 <a:latin typeface="JetBrains Mono"/>
               </a:rPr>
-              <a:t>live · sandbox and testnet only</a:t>
+              <a:t>live · simulated bank, private test chain</a:t>
             </a:r>
           </a:p>
         </p:txBody>
@@ -32804,7 +32810,7 @@
                 </a:solidFill>
                 <a:latin typeface="JetBrains Mono"/>
               </a:rPr>
-              <a:t>live · sandbox and testnet only</a:t>
+              <a:t>live · simulated bank, private test chain</a:t>
             </a:r>
           </a:p>
         </p:txBody>
@@ -37836,7 +37842,7 @@
                 </a:solidFill>
                 <a:latin typeface="JetBrains Mono"/>
               </a:rPr>
-              <a:t>live · sandbox and testnet only  ·  ✂ can be cut</a:t>
+              <a:t>live · simulated bank, private test chain  ·  ✂ can be cut</a:t>
             </a:r>
           </a:p>
         </p:txBody>
@@ -53841,7 +53847,7 @@
                 </a:solidFill>
                 <a:latin typeface="JetBrains Mono"/>
               </a:rPr>
-              <a:t>live · sandbox and testnet only</a:t>
+              <a:t>live · simulated bank, private test chain</a:t>
             </a:r>
           </a:p>
         </p:txBody>
@@ -53958,7 +53964,7 @@
                 </a:solidFill>
                 <a:latin typeface="Inter"/>
               </a:rPr>
-              <a:t>Six volunteers, six cards, one constitution. Nobody types a name in: the chain knows each member from a signature.</a:t>
+              <a:t>Six volunteers, six cards, six phones, one constitution. Nobody types a name in: the chain knows each member from a signature.</a:t>
             </a:r>
           </a:p>
         </p:txBody>
@@ -58873,7 +58879,7 @@
                 </a:solidFill>
                 <a:latin typeface="JetBrains Mono"/>
               </a:rPr>
-              <a:t>live · sandbox and testnet only</a:t>
+              <a:t>live · simulated bank, private test chain</a:t>
             </a:r>
           </a:p>
         </p:txBody>

</xml_diff>

<commit_message>
feat(stage): the constitution on the board, and a moment when all six have signed
zoom constitution (or key 6) fills the screen with the club's constitution: the seven rules the
contract holds the hash of, and six signature lines that fill in, in each member's colour with
their patch and the transaction, as they sign on their phones. When the sixth signature lands,
"Everyone has signed the constitution" comes up with the six members (12 s, or Esc or a click);
only a signature that arrives while the board is watching raises it, not a reload.

fix(stage): closing the run sheet left keyboard focus in its hidden box, so the next D or zoom
key went into it ("djoin sipho") instead of to the board. It blurs on close and is inert while
closed.

Run order and talk/SPEECH.md: DEMO 1 opens on the constitution.

Co-Authored-By: Claude Opus 5.5 <noreply@anthropic.com>
</commit_message>
<xml_diff>
--- a/slides/The-Treasurer-Is-a-Smart-Contract-Light.pptx
+++ b/slides/The-Treasurer-Is-a-Smart-Contract-Light.pptx
@@ -2768,6 +2768,28 @@
           <a:p/>
           <a:p>
             <a:r>
+              <a:t>Run sheet: zoom constitution</a:t>
+            </a:r>
+          </a:p>
+          <a:p/>
+          <a:p>
+            <a:r>
+              <a:t>This is the club's constitution. Seven rules, and six empty lines at the bottom. The contract</a:t>
+            </a:r>
+          </a:p>
+          <a:p>
+            <a:r>
+              <a:t>holds the fingerprint of exactly this text, so nobody can later claim you agreed to something</a:t>
+            </a:r>
+          </a:p>
+          <a:p>
+            <a:r>
+              <a:t>else.</a:t>
+            </a:r>
+          </a:p>
+          <a:p/>
+          <a:p>
+            <a:r>
               <a:t>Committee, take out your phones. Turn your card over and point your camera at the QR on the</a:t>
             </a:r>
           </a:p>
@@ -2813,13 +2835,13 @@
           <a:p/>
           <a:p>
             <a:r>
-              <a:t>[Wait for the minute book line: "Member joined", and "✓ signed in" next to Lerato on the roster.]</a:t>
+              <a:t>[Wait for Lerato's name to land on her signature line.]</a:t>
             </a:r>
           </a:p>
           <a:p/>
           <a:p>
             <a:r>
-              <a:t>And there she is on the right page. Signed in. Nobody typed her name in. The chain knows her</a:t>
+              <a:t>And there she is, on her line. Signed. Nobody typed her name in. The chain knows her</a:t>
             </a:r>
           </a:p>
           <a:p>
@@ -2835,7 +2857,24 @@
           </a:p>
           <a:p>
             <a:r>
-              <a:t>the signing station at the side.]</a:t>
+              <a:t>the signing station at the side. The sixth signature brings up "Everyone has signed the</a:t>
+            </a:r>
+          </a:p>
+          <a:p>
+            <a:r>
+              <a:t>constitution". Let it sit for a beat.]</a:t>
+            </a:r>
+          </a:p>
+          <a:p/>
+          <a:p>
+            <a:r>
+              <a:t>Six strangers, one set of rules, and every signature their own. That's a stokvel.</a:t>
+            </a:r>
+          </a:p>
+          <a:p/>
+          <a:p>
+            <a:r>
+              <a:t>Run sheet: zoom all</a:t>
             </a:r>
           </a:p>
           <a:p/>

</xml_diff>